<commit_message>
Remove copyrighted material from presentation
</commit_message>
<xml_diff>
--- a/Final-Group-Presentation/Project Presentation.pptx
+++ b/Final-Group-Presentation/Project Presentation.pptx
@@ -3411,52 +3411,6 @@
           </a:p>
         </p:txBody>
       </p:sp>
-      <p:pic>
-        <p:nvPicPr>
-          <p:cNvPr id="1026" name="Picture 2" descr="How Many People Have a Top Secret Security Clearance? - ClearanceJobs">
-            <a:extLst>
-              <a:ext uri="{FF2B5EF4-FFF2-40B4-BE49-F238E27FC236}">
-                <a16:creationId xmlns:a16="http://schemas.microsoft.com/office/drawing/2014/main" id="{15959C31-AA58-DD0E-7B85-8ED6B95B5549}"/>
-              </a:ext>
-            </a:extLst>
-          </p:cNvPr>
-          <p:cNvPicPr>
-            <a:picLocks noChangeAspect="1" noChangeArrowheads="1"/>
-          </p:cNvPicPr>
-          <p:nvPr/>
-        </p:nvPicPr>
-        <p:blipFill rotWithShape="1">
-          <a:blip r:embed="rId2">
-            <a:alphaModFix amt="50000"/>
-            <a:extLst>
-              <a:ext uri="{28A0092B-C50C-407E-A947-70E740481C1C}">
-                <a14:useLocalDpi xmlns:a14="http://schemas.microsoft.com/office/drawing/2010/main" val="0"/>
-              </a:ext>
-            </a:extLst>
-          </a:blip>
-          <a:srcRect t="6471" b="5294"/>
-          <a:stretch/>
-        </p:blipFill>
-        <p:spPr bwMode="auto">
-          <a:xfrm>
-            <a:off x="20" y="224119"/>
-            <a:ext cx="12191980" cy="6857999"/>
-          </a:xfrm>
-          <a:prstGeom prst="rect">
-            <a:avLst/>
-          </a:prstGeom>
-          <a:noFill/>
-          <a:extLst>
-            <a:ext uri="{909E8E84-426E-40DD-AFC4-6F175D3DCCD1}">
-              <a14:hiddenFill xmlns:a14="http://schemas.microsoft.com/office/drawing/2010/main">
-                <a:solidFill>
-                  <a:srgbClr val="FFFFFF"/>
-                </a:solidFill>
-              </a14:hiddenFill>
-            </a:ext>
-          </a:extLst>
-        </p:spPr>
-      </p:pic>
       <p:sp>
         <p:nvSpPr>
           <p:cNvPr id="2" name="Title 1">

</xml_diff>